<commit_message>
Deepen slide content: evidence-backed value props, honest production gaps
"Why it matters" bullets were generic platitudes any vendor deck could
make; rewrote each to point at something actually demonstrated in this
session (the forced incident, the DMN table swap, the Node payment
service, the two different failure-handling paths).

Added a new "What this doesn't prove yet" slide to both decks, split into
feature gaps (BPMN patterns not used) and production gaps (auth still
demo/demo, H2 single-node storage, no observability/HA) -- the latter
category didn't exist anywhere in the deck before and is the most
predictable follow-up question this kind of demo gets.

Verified visually in both formats before committing: HTML deck via browser
screenshots, pptx via PowerPoint COM export.
</commit_message>
<xml_diff>
--- a/slides/camunda8-demo.pptx
+++ b/slides/camunda8-demo.pptx
@@ -8240,7 +8240,7 @@
                 </a:solidFill>
                 <a:latin typeface="Segoe UI"/>
               </a:rPr>
-              <a:t>Not logs to reconstruct -- an actual, current picture of what's running and where it's stuck.</a:t>
+              <a:t>We forced a real incident earlier -- Operate showed the exact failed variable and a one-click retry, not a log line to go reconstruct after the fact.</a:t>
             </a:r>
           </a:p>
         </p:txBody>
@@ -8336,7 +8336,7 @@
                 </a:solidFill>
                 <a:latin typeface="Segoe UI"/>
               </a:rPr>
-              <a:t>The gateway condition reads a DMN decision, not a code branch.</a:t>
+              <a:t>The in-stock threshold is a row in dmn/stock-check.dmn, not a Python if -- change the number, redeploy the table, zero code review.</a:t>
             </a:r>
           </a:p>
         </p:txBody>
@@ -8432,7 +8432,7 @@
                 </a:solidFill>
                 <a:latin typeface="Segoe UI"/>
               </a:rPr>
-              <a:t>The order-triggering service is Python; the payment service the connector calls is Node -- proven, not hypothetical.</a:t>
+              <a:t>The order-triggering service is Python; the payment service the connector calls is Node -- proven today, not hypothetical.</a:t>
             </a:r>
           </a:p>
         </p:txBody>
@@ -8528,7 +8528,7 @@
                 </a:solidFill>
                 <a:latin typeface="Segoe UI"/>
               </a:rPr>
-              <a:t>A failed job becomes a visible, fixable incident; a business failure becomes a modeled boundary event.</a:t>
+              <a:t>Two different failure modes, two different outcomes: an unhandled bug becomes a visible incident; a declined payment becomes a modeled path, not a crash. We triggered both.</a:t>
             </a:r>
           </a:p>
         </p:txBody>
@@ -8707,7 +8707,7 @@
                 </a:solidFill>
                 <a:latin typeface="Consolas"/>
               </a:rPr>
-              <a:t>HONEST GAPS</a:t>
+              <a:t>BEFORE ANYONE ASKS</a:t>
             </a:r>
           </a:p>
         </p:txBody>
@@ -8746,7 +8746,7 @@
                 </a:solidFill>
                 <a:latin typeface="Consolas"/>
               </a:rPr>
-              <a:t>What I'd explore next.</a:t>
+              <a:t>What this doesn't prove yet.</a:t>
             </a:r>
           </a:p>
         </p:txBody>
@@ -8785,456 +8785,21 @@
                 </a:solidFill>
                 <a:latin typeface="Segoe UI"/>
               </a:rPr>
-              <a:t>Breadth is covered. These are the remaining depth items -- none need new infrastructure.</a:t>
-            </a:r>
-          </a:p>
-        </p:txBody>
-      </p:sp>
-      <p:sp>
-        <p:nvSpPr>
-          <p:cNvPr id="6" name="Oval 5"/>
-          <p:cNvSpPr/>
-          <p:nvPr/>
-        </p:nvSpPr>
-        <p:spPr>
-          <a:xfrm>
-            <a:off x="685800" y="2404872"/>
-            <a:ext cx="109728" cy="109728"/>
-          </a:xfrm>
-          <a:prstGeom prst="ellipse">
-            <a:avLst/>
-          </a:prstGeom>
-          <a:solidFill>
-            <a:srgbClr val="E8871F"/>
-          </a:solidFill>
-          <a:ln>
-            <a:noFill/>
-          </a:ln>
-          <a:effectLst/>
-        </p:spPr>
-        <p:style>
-          <a:lnRef idx="1">
-            <a:schemeClr val="accent1"/>
-          </a:lnRef>
-          <a:fillRef idx="3">
-            <a:schemeClr val="accent1"/>
-          </a:fillRef>
-          <a:effectRef idx="2">
-            <a:schemeClr val="accent1"/>
-          </a:effectRef>
-          <a:fontRef idx="minor">
-            <a:schemeClr val="lt1"/>
-          </a:fontRef>
-        </p:style>
-        <p:txBody>
-          <a:bodyPr rtlCol="0" anchor="ctr"/>
-          <a:lstStyle/>
-          <a:p>
-            <a:pPr algn="ctr"/>
-          </a:p>
-        </p:txBody>
-      </p:sp>
-      <p:sp>
-        <p:nvSpPr>
-          <p:cNvPr id="7" name="TextBox 6"/>
+              <a:t>Breadth of BPMN concepts is covered. Two different kinds of gap remain, and they're not the same kind of problem.</a:t>
+            </a:r>
+          </a:p>
+        </p:txBody>
+      </p:sp>
+      <p:sp>
+        <p:nvSpPr>
+          <p:cNvPr id="6" name="TextBox 5"/>
           <p:cNvSpPr txBox="1"/>
           <p:nvPr/>
         </p:nvSpPr>
         <p:spPr>
           <a:xfrm>
-            <a:off x="1005840" y="2286000"/>
-            <a:ext cx="10058400" cy="777240"/>
-          </a:xfrm>
-          <a:prstGeom prst="rect">
-            <a:avLst/>
-          </a:prstGeom>
-          <a:noFill/>
-        </p:spPr>
-        <p:txBody>
-          <a:bodyPr wrap="square">
-            <a:spAutoFit/>
-          </a:bodyPr>
-          <a:lstStyle/>
-          <a:p>
-            <a:r>
-              <a:rPr b="1" sz="1450">
-                <a:solidFill>
-                  <a:srgbClr val="12151B"/>
-                </a:solidFill>
-                <a:latin typeface="Segoe UI"/>
-              </a:rPr>
-              <a:t>Parallel / inclusive gateways  </a:t>
-            </a:r>
-            <a:r>
-              <a:rPr sz="1450">
-                <a:solidFill>
-                  <a:srgbClr val="566073"/>
-                </a:solidFill>
-                <a:latin typeface="Segoe UI"/>
-              </a:rPr>
-              <a:t>AND/OR splits -- today there's only the exclusive gateway.</a:t>
-            </a:r>
-          </a:p>
-        </p:txBody>
-      </p:sp>
-      <p:sp>
-        <p:nvSpPr>
-          <p:cNvPr id="8" name="Oval 7"/>
-          <p:cNvSpPr/>
-          <p:nvPr/>
-        </p:nvSpPr>
-        <p:spPr>
-          <a:xfrm>
-            <a:off x="685800" y="3182112"/>
-            <a:ext cx="109728" cy="109728"/>
-          </a:xfrm>
-          <a:prstGeom prst="ellipse">
-            <a:avLst/>
-          </a:prstGeom>
-          <a:solidFill>
-            <a:srgbClr val="E8871F"/>
-          </a:solidFill>
-          <a:ln>
-            <a:noFill/>
-          </a:ln>
-          <a:effectLst/>
-        </p:spPr>
-        <p:style>
-          <a:lnRef idx="1">
-            <a:schemeClr val="accent1"/>
-          </a:lnRef>
-          <a:fillRef idx="3">
-            <a:schemeClr val="accent1"/>
-          </a:fillRef>
-          <a:effectRef idx="2">
-            <a:schemeClr val="accent1"/>
-          </a:effectRef>
-          <a:fontRef idx="minor">
-            <a:schemeClr val="lt1"/>
-          </a:fontRef>
-        </p:style>
-        <p:txBody>
-          <a:bodyPr rtlCol="0" anchor="ctr"/>
-          <a:lstStyle/>
-          <a:p>
-            <a:pPr algn="ctr"/>
-          </a:p>
-        </p:txBody>
-      </p:sp>
-      <p:sp>
-        <p:nvSpPr>
-          <p:cNvPr id="9" name="TextBox 8"/>
-          <p:cNvSpPr txBox="1"/>
-          <p:nvPr/>
-        </p:nvSpPr>
-        <p:spPr>
-          <a:xfrm>
-            <a:off x="1005840" y="3063240"/>
-            <a:ext cx="10058400" cy="777240"/>
-          </a:xfrm>
-          <a:prstGeom prst="rect">
-            <a:avLst/>
-          </a:prstGeom>
-          <a:noFill/>
-        </p:spPr>
-        <p:txBody>
-          <a:bodyPr wrap="square">
-            <a:spAutoFit/>
-          </a:bodyPr>
-          <a:lstStyle/>
-          <a:p>
-            <a:r>
-              <a:rPr b="1" sz="1450">
-                <a:solidFill>
-                  <a:srgbClr val="12151B"/>
-                </a:solidFill>
-                <a:latin typeface="Segoe UI"/>
-              </a:rPr>
-              <a:t>Compensation events  </a:t>
-            </a:r>
-            <a:r>
-              <a:rPr sz="1450">
-                <a:solidFill>
-                  <a:srgbClr val="566073"/>
-                </a:solidFill>
-                <a:latin typeface="Segoe UI"/>
-              </a:rPr>
-              <a:t>The "undo" pattern -- Cancel Order doesn't yet roll back a reservation or a charge.</a:t>
-            </a:r>
-          </a:p>
-        </p:txBody>
-      </p:sp>
-      <p:sp>
-        <p:nvSpPr>
-          <p:cNvPr id="10" name="Oval 9"/>
-          <p:cNvSpPr/>
-          <p:nvPr/>
-        </p:nvSpPr>
-        <p:spPr>
-          <a:xfrm>
-            <a:off x="685800" y="3959352"/>
-            <a:ext cx="109728" cy="109728"/>
-          </a:xfrm>
-          <a:prstGeom prst="ellipse">
-            <a:avLst/>
-          </a:prstGeom>
-          <a:solidFill>
-            <a:srgbClr val="E8871F"/>
-          </a:solidFill>
-          <a:ln>
-            <a:noFill/>
-          </a:ln>
-          <a:effectLst/>
-        </p:spPr>
-        <p:style>
-          <a:lnRef idx="1">
-            <a:schemeClr val="accent1"/>
-          </a:lnRef>
-          <a:fillRef idx="3">
-            <a:schemeClr val="accent1"/>
-          </a:fillRef>
-          <a:effectRef idx="2">
-            <a:schemeClr val="accent1"/>
-          </a:effectRef>
-          <a:fontRef idx="minor">
-            <a:schemeClr val="lt1"/>
-          </a:fontRef>
-        </p:style>
-        <p:txBody>
-          <a:bodyPr rtlCol="0" anchor="ctr"/>
-          <a:lstStyle/>
-          <a:p>
-            <a:pPr algn="ctr"/>
-          </a:p>
-        </p:txBody>
-      </p:sp>
-      <p:sp>
-        <p:nvSpPr>
-          <p:cNvPr id="11" name="TextBox 10"/>
-          <p:cNvSpPr txBox="1"/>
-          <p:nvPr/>
-        </p:nvSpPr>
-        <p:spPr>
-          <a:xfrm>
-            <a:off x="1005840" y="3840480"/>
-            <a:ext cx="10058400" cy="777240"/>
-          </a:xfrm>
-          <a:prstGeom prst="rect">
-            <a:avLst/>
-          </a:prstGeom>
-          <a:noFill/>
-        </p:spPr>
-        <p:txBody>
-          <a:bodyPr wrap="square">
-            <a:spAutoFit/>
-          </a:bodyPr>
-          <a:lstStyle/>
-          <a:p>
-            <a:r>
-              <a:rPr b="1" sz="1450">
-                <a:solidFill>
-                  <a:srgbClr val="12151B"/>
-                </a:solidFill>
-                <a:latin typeface="Segoe UI"/>
-              </a:rPr>
-              <a:t>Message start events  </a:t>
-            </a:r>
-            <a:r>
-              <a:rPr sz="1450">
-                <a:solidFill>
-                  <a:srgbClr val="566073"/>
-                </a:solidFill>
-                <a:latin typeface="Segoe UI"/>
-              </a:rPr>
-              <a:t>Starting an instance from an external event, not just a REST call.</a:t>
-            </a:r>
-          </a:p>
-        </p:txBody>
-      </p:sp>
-      <p:sp>
-        <p:nvSpPr>
-          <p:cNvPr id="12" name="Oval 11"/>
-          <p:cNvSpPr/>
-          <p:nvPr/>
-        </p:nvSpPr>
-        <p:spPr>
-          <a:xfrm>
-            <a:off x="685800" y="4736592"/>
-            <a:ext cx="109728" cy="109728"/>
-          </a:xfrm>
-          <a:prstGeom prst="ellipse">
-            <a:avLst/>
-          </a:prstGeom>
-          <a:solidFill>
-            <a:srgbClr val="E8871F"/>
-          </a:solidFill>
-          <a:ln>
-            <a:noFill/>
-          </a:ln>
-          <a:effectLst/>
-        </p:spPr>
-        <p:style>
-          <a:lnRef idx="1">
-            <a:schemeClr val="accent1"/>
-          </a:lnRef>
-          <a:fillRef idx="3">
-            <a:schemeClr val="accent1"/>
-          </a:fillRef>
-          <a:effectRef idx="2">
-            <a:schemeClr val="accent1"/>
-          </a:effectRef>
-          <a:fontRef idx="minor">
-            <a:schemeClr val="lt1"/>
-          </a:fontRef>
-        </p:style>
-        <p:txBody>
-          <a:bodyPr rtlCol="0" anchor="ctr"/>
-          <a:lstStyle/>
-          <a:p>
-            <a:pPr algn="ctr"/>
-          </a:p>
-        </p:txBody>
-      </p:sp>
-      <p:sp>
-        <p:nvSpPr>
-          <p:cNvPr id="13" name="TextBox 12"/>
-          <p:cNvSpPr txBox="1"/>
-          <p:nvPr/>
-        </p:nvSpPr>
-        <p:spPr>
-          <a:xfrm>
-            <a:off x="1005840" y="4617720"/>
-            <a:ext cx="10058400" cy="777240"/>
-          </a:xfrm>
-          <a:prstGeom prst="rect">
-            <a:avLst/>
-          </a:prstGeom>
-          <a:noFill/>
-        </p:spPr>
-        <p:txBody>
-          <a:bodyPr wrap="square">
-            <a:spAutoFit/>
-          </a:bodyPr>
-          <a:lstStyle/>
-          <a:p>
-            <a:r>
-              <a:rPr b="1" sz="1450">
-                <a:solidFill>
-                  <a:srgbClr val="12151B"/>
-                </a:solidFill>
-                <a:latin typeface="Segoe UI"/>
-              </a:rPr>
-              <a:t>Process versioning &amp; migration  </a:t>
-            </a:r>
-            <a:r>
-              <a:rPr sz="1450">
-                <a:solidFill>
-                  <a:srgbClr val="566073"/>
-                </a:solidFill>
-                <a:latin typeface="Segoe UI"/>
-              </a:rPr>
-              <a:t>Deploying v2 of a running process and migrating in-flight instances.</a:t>
-            </a:r>
-          </a:p>
-        </p:txBody>
-      </p:sp>
-      <p:sp>
-        <p:nvSpPr>
-          <p:cNvPr id="14" name="Oval 13"/>
-          <p:cNvSpPr/>
-          <p:nvPr/>
-        </p:nvSpPr>
-        <p:spPr>
-          <a:xfrm>
-            <a:off x="685800" y="5513832"/>
-            <a:ext cx="109728" cy="109728"/>
-          </a:xfrm>
-          <a:prstGeom prst="ellipse">
-            <a:avLst/>
-          </a:prstGeom>
-          <a:solidFill>
-            <a:srgbClr val="E8871F"/>
-          </a:solidFill>
-          <a:ln>
-            <a:noFill/>
-          </a:ln>
-          <a:effectLst/>
-        </p:spPr>
-        <p:style>
-          <a:lnRef idx="1">
-            <a:schemeClr val="accent1"/>
-          </a:lnRef>
-          <a:fillRef idx="3">
-            <a:schemeClr val="accent1"/>
-          </a:fillRef>
-          <a:effectRef idx="2">
-            <a:schemeClr val="accent1"/>
-          </a:effectRef>
-          <a:fontRef idx="minor">
-            <a:schemeClr val="lt1"/>
-          </a:fontRef>
-        </p:style>
-        <p:txBody>
-          <a:bodyPr rtlCol="0" anchor="ctr"/>
-          <a:lstStyle/>
-          <a:p>
-            <a:pPr algn="ctr"/>
-          </a:p>
-        </p:txBody>
-      </p:sp>
-      <p:sp>
-        <p:nvSpPr>
-          <p:cNvPr id="15" name="TextBox 14"/>
-          <p:cNvSpPr txBox="1"/>
-          <p:nvPr/>
-        </p:nvSpPr>
-        <p:spPr>
-          <a:xfrm>
-            <a:off x="1005840" y="5394960"/>
-            <a:ext cx="10058400" cy="777240"/>
-          </a:xfrm>
-          <a:prstGeom prst="rect">
-            <a:avLst/>
-          </a:prstGeom>
-          <a:noFill/>
-        </p:spPr>
-        <p:txBody>
-          <a:bodyPr wrap="square">
-            <a:spAutoFit/>
-          </a:bodyPr>
-          <a:lstStyle/>
-          <a:p>
-            <a:r>
-              <a:rPr b="1" sz="1450">
-                <a:solidFill>
-                  <a:srgbClr val="12151B"/>
-                </a:solidFill>
-                <a:latin typeface="Segoe UI"/>
-              </a:rPr>
-              <a:t>A second job-worker language  </a:t>
-            </a:r>
-            <a:r>
-              <a:rPr sz="1450">
-                <a:solidFill>
-                  <a:srgbClr val="566073"/>
-                </a:solidFill>
-                <a:latin typeface="Segoe UI"/>
-              </a:rPr>
-              <a:t>payment_service.js proved connector-called services are polyglot; order_workers.py is still Python-only.</a:t>
-            </a:r>
-          </a:p>
-        </p:txBody>
-      </p:sp>
-      <p:sp>
-        <p:nvSpPr>
-          <p:cNvPr id="16" name="TextBox 15"/>
-          <p:cNvSpPr txBox="1"/>
-          <p:nvPr/>
-        </p:nvSpPr>
-        <p:spPr>
-          <a:xfrm>
-            <a:off x="640080" y="6492240"/>
-            <a:ext cx="3657600" cy="274320"/>
+            <a:off x="640080" y="2514600"/>
+            <a:ext cx="5212080" cy="320040"/>
           </a:xfrm>
           <a:prstGeom prst="rect">
             <a:avLst/>
@@ -9253,6 +8818,381 @@
               </a:lnSpc>
             </a:pPr>
             <a:r>
+              <a:rPr sz="1300" b="1">
+                <a:solidFill>
+                  <a:srgbClr val="566073"/>
+                </a:solidFill>
+                <a:latin typeface="Consolas"/>
+              </a:rPr>
+              <a:t>FEATURE GAPS</a:t>
+            </a:r>
+          </a:p>
+        </p:txBody>
+      </p:sp>
+      <p:sp>
+        <p:nvSpPr>
+          <p:cNvPr id="7" name="TextBox 6"/>
+          <p:cNvSpPr txBox="1"/>
+          <p:nvPr/>
+        </p:nvSpPr>
+        <p:spPr>
+          <a:xfrm>
+            <a:off x="640080" y="2926080"/>
+            <a:ext cx="5212080" cy="822960"/>
+          </a:xfrm>
+          <a:prstGeom prst="rect">
+            <a:avLst/>
+          </a:prstGeom>
+          <a:noFill/>
+        </p:spPr>
+        <p:txBody>
+          <a:bodyPr wrap="square">
+            <a:spAutoFit/>
+          </a:bodyPr>
+          <a:lstStyle/>
+          <a:p>
+            <a:r>
+              <a:rPr b="1" sz="1300">
+                <a:solidFill>
+                  <a:srgbClr val="12151B"/>
+                </a:solidFill>
+                <a:latin typeface="Segoe UI"/>
+              </a:rPr>
+              <a:t>Parallel / inclusive gateways -- </a:t>
+            </a:r>
+            <a:r>
+              <a:rPr sz="1300">
+                <a:solidFill>
+                  <a:srgbClr val="566073"/>
+                </a:solidFill>
+                <a:latin typeface="Segoe UI"/>
+              </a:rPr>
+              <a:t>only the exclusive gateway exists today.</a:t>
+            </a:r>
+          </a:p>
+        </p:txBody>
+      </p:sp>
+      <p:sp>
+        <p:nvSpPr>
+          <p:cNvPr id="8" name="TextBox 7"/>
+          <p:cNvSpPr txBox="1"/>
+          <p:nvPr/>
+        </p:nvSpPr>
+        <p:spPr>
+          <a:xfrm>
+            <a:off x="640080" y="3794760"/>
+            <a:ext cx="5212080" cy="822960"/>
+          </a:xfrm>
+          <a:prstGeom prst="rect">
+            <a:avLst/>
+          </a:prstGeom>
+          <a:noFill/>
+        </p:spPr>
+        <p:txBody>
+          <a:bodyPr wrap="square">
+            <a:spAutoFit/>
+          </a:bodyPr>
+          <a:lstStyle/>
+          <a:p>
+            <a:r>
+              <a:rPr b="1" sz="1300">
+                <a:solidFill>
+                  <a:srgbClr val="12151B"/>
+                </a:solidFill>
+                <a:latin typeface="Segoe UI"/>
+              </a:rPr>
+              <a:t>Compensation events -- </a:t>
+            </a:r>
+            <a:r>
+              <a:rPr sz="1300">
+                <a:solidFill>
+                  <a:srgbClr val="566073"/>
+                </a:solidFill>
+                <a:latin typeface="Segoe UI"/>
+              </a:rPr>
+              <a:t>Cancel Order doesn't roll back a reservation or a charge.</a:t>
+            </a:r>
+          </a:p>
+        </p:txBody>
+      </p:sp>
+      <p:sp>
+        <p:nvSpPr>
+          <p:cNvPr id="9" name="TextBox 8"/>
+          <p:cNvSpPr txBox="1"/>
+          <p:nvPr/>
+        </p:nvSpPr>
+        <p:spPr>
+          <a:xfrm>
+            <a:off x="640080" y="4663440"/>
+            <a:ext cx="5212080" cy="822960"/>
+          </a:xfrm>
+          <a:prstGeom prst="rect">
+            <a:avLst/>
+          </a:prstGeom>
+          <a:noFill/>
+        </p:spPr>
+        <p:txBody>
+          <a:bodyPr wrap="square">
+            <a:spAutoFit/>
+          </a:bodyPr>
+          <a:lstStyle/>
+          <a:p>
+            <a:r>
+              <a:rPr b="1" sz="1300">
+                <a:solidFill>
+                  <a:srgbClr val="12151B"/>
+                </a:solidFill>
+                <a:latin typeface="Segoe UI"/>
+              </a:rPr>
+              <a:t>Process versioning &amp; migration -- </a:t>
+            </a:r>
+            <a:r>
+              <a:rPr sz="1300">
+                <a:solidFill>
+                  <a:srgbClr val="566073"/>
+                </a:solidFill>
+                <a:latin typeface="Segoe UI"/>
+              </a:rPr>
+              <a:t>deploying v2 of a running process, live.</a:t>
+            </a:r>
+          </a:p>
+        </p:txBody>
+      </p:sp>
+      <p:sp>
+        <p:nvSpPr>
+          <p:cNvPr id="10" name="TextBox 9"/>
+          <p:cNvSpPr txBox="1"/>
+          <p:nvPr/>
+        </p:nvSpPr>
+        <p:spPr>
+          <a:xfrm>
+            <a:off x="6309360" y="2514600"/>
+            <a:ext cx="5212080" cy="320040"/>
+          </a:xfrm>
+          <a:prstGeom prst="rect">
+            <a:avLst/>
+          </a:prstGeom>
+          <a:noFill/>
+        </p:spPr>
+        <p:txBody>
+          <a:bodyPr wrap="square" anchor="t" lIns="0" rIns="0" tIns="0" bIns="0">
+            <a:spAutoFit/>
+          </a:bodyPr>
+          <a:lstStyle/>
+          <a:p>
+            <a:pPr algn="l">
+              <a:lnSpc>
+                <a:spcPct val="100000"/>
+              </a:lnSpc>
+            </a:pPr>
+            <a:r>
+              <a:rPr sz="1300" b="1">
+                <a:solidFill>
+                  <a:srgbClr val="E8871F"/>
+                </a:solidFill>
+                <a:latin typeface="Consolas"/>
+              </a:rPr>
+              <a:t>PRODUCTION GAPS</a:t>
+            </a:r>
+          </a:p>
+        </p:txBody>
+      </p:sp>
+      <p:sp>
+        <p:nvSpPr>
+          <p:cNvPr id="11" name="TextBox 10"/>
+          <p:cNvSpPr txBox="1"/>
+          <p:nvPr/>
+        </p:nvSpPr>
+        <p:spPr>
+          <a:xfrm>
+            <a:off x="6309360" y="2926080"/>
+            <a:ext cx="5212080" cy="822960"/>
+          </a:xfrm>
+          <a:prstGeom prst="rect">
+            <a:avLst/>
+          </a:prstGeom>
+          <a:noFill/>
+        </p:spPr>
+        <p:txBody>
+          <a:bodyPr wrap="square">
+            <a:spAutoFit/>
+          </a:bodyPr>
+          <a:lstStyle/>
+          <a:p>
+            <a:r>
+              <a:rPr b="1" sz="1300">
+                <a:solidFill>
+                  <a:srgbClr val="12151B"/>
+                </a:solidFill>
+                <a:latin typeface="Segoe UI"/>
+              </a:rPr>
+              <a:t>Auth -- </a:t>
+            </a:r>
+            <a:r>
+              <a:rPr sz="1300">
+                <a:solidFill>
+                  <a:srgbClr val="566073"/>
+                </a:solidFill>
+                <a:latin typeface="Segoe UI"/>
+              </a:rPr>
+              <a:t>still the default demo/demo login; Identity untouched.</a:t>
+            </a:r>
+          </a:p>
+        </p:txBody>
+      </p:sp>
+      <p:sp>
+        <p:nvSpPr>
+          <p:cNvPr id="12" name="TextBox 11"/>
+          <p:cNvSpPr txBox="1"/>
+          <p:nvPr/>
+        </p:nvSpPr>
+        <p:spPr>
+          <a:xfrm>
+            <a:off x="6309360" y="3794760"/>
+            <a:ext cx="5212080" cy="822960"/>
+          </a:xfrm>
+          <a:prstGeom prst="rect">
+            <a:avLst/>
+          </a:prstGeom>
+          <a:noFill/>
+        </p:spPr>
+        <p:txBody>
+          <a:bodyPr wrap="square">
+            <a:spAutoFit/>
+          </a:bodyPr>
+          <a:lstStyle/>
+          <a:p>
+            <a:r>
+              <a:rPr b="1" sz="1300">
+                <a:solidFill>
+                  <a:srgbClr val="12151B"/>
+                </a:solidFill>
+                <a:latin typeface="Segoe UI"/>
+              </a:rPr>
+              <a:t>Storage -- </a:t>
+            </a:r>
+            <a:r>
+              <a:rPr sz="1300">
+                <a:solidFill>
+                  <a:srgbClr val="566073"/>
+                </a:solidFill>
+                <a:latin typeface="Segoe UI"/>
+              </a:rPr>
+              <a:t>H2, single-node, file-based; production needs the Elasticsearch exporter or SaaS.</a:t>
+            </a:r>
+          </a:p>
+        </p:txBody>
+      </p:sp>
+      <p:sp>
+        <p:nvSpPr>
+          <p:cNvPr id="13" name="TextBox 12"/>
+          <p:cNvSpPr txBox="1"/>
+          <p:nvPr/>
+        </p:nvSpPr>
+        <p:spPr>
+          <a:xfrm>
+            <a:off x="6309360" y="4663440"/>
+            <a:ext cx="5212080" cy="822960"/>
+          </a:xfrm>
+          <a:prstGeom prst="rect">
+            <a:avLst/>
+          </a:prstGeom>
+          <a:noFill/>
+        </p:spPr>
+        <p:txBody>
+          <a:bodyPr wrap="square">
+            <a:spAutoFit/>
+          </a:bodyPr>
+          <a:lstStyle/>
+          <a:p>
+            <a:r>
+              <a:rPr b="1" sz="1300">
+                <a:solidFill>
+                  <a:srgbClr val="12151B"/>
+                </a:solidFill>
+                <a:latin typeface="Segoe UI"/>
+              </a:rPr>
+              <a:t>Observability &amp; HA -- </a:t>
+            </a:r>
+            <a:r>
+              <a:rPr sz="1300">
+                <a:solidFill>
+                  <a:srgbClr val="566073"/>
+                </a:solidFill>
+                <a:latin typeface="Segoe UI"/>
+              </a:rPr>
+              <a:t>Operate's UI only, no alerting; one broker container, not a cluster.</a:t>
+            </a:r>
+          </a:p>
+        </p:txBody>
+      </p:sp>
+      <p:sp>
+        <p:nvSpPr>
+          <p:cNvPr id="14" name="TextBox 13"/>
+          <p:cNvSpPr txBox="1"/>
+          <p:nvPr/>
+        </p:nvSpPr>
+        <p:spPr>
+          <a:xfrm>
+            <a:off x="640080" y="6035040"/>
+            <a:ext cx="10515600" cy="640080"/>
+          </a:xfrm>
+          <a:prstGeom prst="rect">
+            <a:avLst/>
+          </a:prstGeom>
+          <a:noFill/>
+        </p:spPr>
+        <p:txBody>
+          <a:bodyPr wrap="square" anchor="t" lIns="0" rIns="0" tIns="0" bIns="0">
+            <a:spAutoFit/>
+          </a:bodyPr>
+          <a:lstStyle/>
+          <a:p>
+            <a:pPr algn="l">
+              <a:lnSpc>
+                <a:spcPct val="120000"/>
+              </a:lnSpc>
+            </a:pPr>
+            <a:r>
+              <a:rPr sz="1200" b="0">
+                <a:solidFill>
+                  <a:srgbClr val="566073"/>
+                </a:solidFill>
+                <a:latin typeface="Segoe UI"/>
+              </a:rPr>
+              <a:t>The left column is "haven't gotten to it yet." The right column is "deliberately out of scope for a local demo" -- worth being explicit about which is which.</a:t>
+            </a:r>
+          </a:p>
+        </p:txBody>
+      </p:sp>
+      <p:sp>
+        <p:nvSpPr>
+          <p:cNvPr id="15" name="TextBox 14"/>
+          <p:cNvSpPr txBox="1"/>
+          <p:nvPr/>
+        </p:nvSpPr>
+        <p:spPr>
+          <a:xfrm>
+            <a:off x="640080" y="6492240"/>
+            <a:ext cx="3657600" cy="274320"/>
+          </a:xfrm>
+          <a:prstGeom prst="rect">
+            <a:avLst/>
+          </a:prstGeom>
+          <a:noFill/>
+        </p:spPr>
+        <p:txBody>
+          <a:bodyPr wrap="square" anchor="t" lIns="0" rIns="0" tIns="0" bIns="0">
+            <a:spAutoFit/>
+          </a:bodyPr>
+          <a:lstStyle/>
+          <a:p>
+            <a:pPr algn="l">
+              <a:lnSpc>
+                <a:spcPct val="100000"/>
+              </a:lnSpc>
+            </a:pPr>
+            <a:r>
               <a:rPr sz="1000" b="0">
                 <a:solidFill>
                   <a:srgbClr val="566073"/>
@@ -9266,7 +9206,7 @@
       </p:sp>
       <p:sp>
         <p:nvSpPr>
-          <p:cNvPr id="17" name="TextBox 16"/>
+          <p:cNvPr id="16" name="TextBox 15"/>
           <p:cNvSpPr txBox="1"/>
           <p:nvPr/>
         </p:nvSpPr>

</xml_diff>